<commit_message>
fix(ui): resolve blue screen issue by restoring clear map tiles and responsive rail visibility
</commit_message>
<xml_diff>
--- a/ORCA_4.0_SIH_Deck.pptx
+++ b/ORCA_4.0_SIH_Deck.pptx
@@ -9327,7 +9327,7 @@
                 </a:solidFill>
                 <a:latin typeface="Calibri"/>
               </a:rPr>
-              <a:t>live, no creds</a:t>
+              <a:t>5 live providers, no creds</a:t>
             </a:r>
           </a:p>
         </p:txBody>
@@ -10047,7 +10047,7 @@
                 </a:solidFill>
                 <a:latin typeface="Calibri"/>
               </a:rPr>
-              <a:t>CANONICAL NORMALIZATION  ·  18 params  ·  provenance</a:t>
+              <a:t>CANONICAL NORMALIZATION  ·  18 parameters  ·  provenance</a:t>
             </a:r>
           </a:p>
         </p:txBody>
@@ -11331,7 +11331,42 @@
                 <a:latin typeface="Calibri"/>
               </a:rPr>
               <a:t>LIVE DEMO:  /api/v1/assess-now
-Kanyakumari → MRSI 75 / 100</a:t>
+Kanyakumari → MRSI = 75 / 100</a:t>
+            </a:r>
+          </a:p>
+        </p:txBody>
+      </p:sp>
+      <p:sp>
+        <p:nvSpPr>
+          <p:cNvPr id="17477" name="TextBox 17476"/>
+          <p:cNvSpPr txBox="1"/>
+          <p:nvPr/>
+        </p:nvSpPr>
+        <p:spPr>
+          <a:xfrm>
+            <a:off x="457200" y="5349240"/>
+            <a:ext cx="11274552" cy="320040"/>
+          </a:xfrm>
+          <a:prstGeom prst="rect">
+            <a:avLst/>
+          </a:prstGeom>
+          <a:noFill/>
+        </p:spPr>
+        <p:txBody>
+          <a:bodyPr wrap="square" lIns="0" rIns="0" tIns="0" bIns="0" anchor="t">
+            <a:spAutoFit/>
+          </a:bodyPr>
+          <a:lstStyle/>
+          <a:p>
+            <a:pPr algn="ctr"/>
+            <a:r>
+              <a:rPr sz="1000" b="0" i="1">
+                <a:solidFill>
+                  <a:srgbClr val="F59E0B"/>
+                </a:solidFill>
+                <a:latin typeface="Calibri"/>
+              </a:rPr>
+              <a:t>Note: ORCA's multi-objective Pareto route planner is a v0 placeholder today — per-segment MRSI is the production route engine.</a:t>
             </a:r>
           </a:p>
         </p:txBody>
@@ -13337,7 +13372,7 @@
                 </a:solidFill>
                 <a:latin typeface="Calibri"/>
               </a:rPr>
-              <a:t>(indicative)</a:t>
+              <a:t>(indicative · vendor-dependent)</a:t>
             </a:r>
           </a:p>
         </p:txBody>
@@ -13530,7 +13565,7 @@
                 </a:solidFill>
                 <a:latin typeface="Calibri"/>
               </a:rPr>
-              <a:t>(indicative)</a:t>
+              <a:t>(indicative · vendor-dependent)</a:t>
             </a:r>
           </a:p>
         </p:txBody>
@@ -13723,7 +13758,7 @@
                 </a:solidFill>
                 <a:latin typeface="Calibri"/>
               </a:rPr>
-              <a:t>(indicative)</a:t>
+              <a:t>(indicative · vendor-dependent)</a:t>
             </a:r>
           </a:p>
         </p:txBody>

</xml_diff>